<commit_message>
Final revision Poster and Link for video
</commit_message>
<xml_diff>
--- a/Presentation poster.pptx
+++ b/Presentation poster.pptx
@@ -119,6 +119,34 @@
     </p:ext>
   </p:extLst>
 </p:presentation>
+</file>
+
+<file path=ppt/ink/ink1.xml><?xml version="1.0" encoding="utf-8"?>
+<inkml:ink xmlns:inkml="http://www.w3.org/2003/InkML">
+  <inkml:definitions>
+    <inkml:context xml:id="ctx0">
+      <inkml:inkSource xml:id="inkSrc0">
+        <inkml:traceFormat>
+          <inkml:channel name="X" type="integer" min="-2.14748E9" max="2.14748E9" units="cm"/>
+          <inkml:channel name="Y" type="integer" min="-2.14748E9" max="2.14748E9" units="cm"/>
+          <inkml:channel name="F" type="integer" max="32767" units="dev"/>
+        </inkml:traceFormat>
+        <inkml:channelProperties>
+          <inkml:channelProperty channel="X" name="resolution" value="1000" units="1/cm"/>
+          <inkml:channelProperty channel="Y" name="resolution" value="1000" units="1/cm"/>
+          <inkml:channelProperty channel="F" name="resolution" value="0" units="1/dev"/>
+        </inkml:channelProperties>
+      </inkml:inkSource>
+      <inkml:timestamp xml:id="ts0" timeString="2026-10-30T11:58:17.706"/>
+    </inkml:context>
+    <inkml:brush xml:id="br0">
+      <inkml:brushProperty name="width" value="0.05292" units="cm"/>
+      <inkml:brushProperty name="height" value="0.05292" units="cm"/>
+      <inkml:brushProperty name="color" value="#FF0000"/>
+    </inkml:brush>
+  </inkml:definitions>
+  <inkml:trace contextRef="#ctx0" brushRef="#br0">62843 7418 24575,'0'0'0</inkml:trace>
+</inkml:ink>
 </file>
 
 <file path=ppt/notesMasters/notesMaster1.xml><?xml version="1.0" encoding="utf-8"?>
@@ -701,7 +729,7 @@
         </p:nvSpPr>
         <p:spPr>
           <a:xfrm>
-            <a:off x="411480" y="411480"/>
+            <a:off x="411480" y="431787"/>
             <a:ext cx="28145232" cy="1965960"/>
           </a:xfrm>
           <a:prstGeom prst="roundRect">
@@ -710,10 +738,17 @@
             </a:avLst>
           </a:prstGeom>
           <a:solidFill>
-            <a:schemeClr val="tx2"/>
+            <a:srgbClr val="F5B701"/>
           </a:solidFill>
           <a:ln/>
         </p:spPr>
+        <p:txBody>
+          <a:bodyPr/>
+          <a:lstStyle/>
+          <a:p>
+            <a:endParaRPr lang="en-US" dirty="0"/>
+          </a:p>
+        </p:txBody>
       </p:sp>
       <p:sp>
         <p:nvSpPr>
@@ -748,7 +783,7 @@
                 <a:ea typeface="Cambria" pitchFamily="34" charset="-122"/>
                 <a:cs typeface="Lucida Sans Unicode" panose="020B0602030504020204" pitchFamily="34" charset="0"/>
               </a:rPr>
-              <a:t>CA1 - Algorithms &amp; Constructs: Food Storage System</a:t>
+              <a:t>Algorithms &amp; Constructs: Food Storage System</a:t>
             </a:r>
             <a:endParaRPr lang="en-US" sz="4600" dirty="0">
               <a:latin typeface="Franklin Gothic Medium" panose="020B0603020102020204" pitchFamily="34" charset="0"/>
@@ -784,12 +819,16 @@
             <a:r>
               <a:rPr lang="en-US" sz="2200" i="1" dirty="0">
                 <a:solidFill>
-                  <a:schemeClr val="accent2"/>
+                  <a:srgbClr val="002060"/>
                 </a:solidFill>
               </a:rPr>
               <a:t>A Java console application that stores fast-food items in a circular queue (FIFO)</a:t>
             </a:r>
-            <a:endParaRPr lang="en-US" sz="2200" dirty="0"/>
+            <a:endParaRPr lang="en-US" sz="2200" dirty="0">
+              <a:solidFill>
+                <a:srgbClr val="002060"/>
+              </a:solidFill>
+            </a:endParaRPr>
           </a:p>
         </p:txBody>
       </p:sp>
@@ -820,12 +859,13 @@
             <a:r>
               <a:rPr lang="en-US" sz="1600" dirty="0">
                 <a:solidFill>
-                  <a:schemeClr val="accent4"/>
+                  <a:schemeClr val="accent6">
+                    <a:lumMod val="75000"/>
+                  </a:schemeClr>
                 </a:solidFill>
               </a:rPr>
               <a:t>Students: Flavia Castro &amp; Sissyane Rodrigues  |  Lecturer: Taufique Ahmed  |  BSc (Hons) in Computing  |  CCT College Dublin</a:t>
             </a:r>
-            <a:endParaRPr lang="en-US" sz="1600" dirty="0"/>
           </a:p>
         </p:txBody>
       </p:sp>
@@ -837,8 +877,8 @@
         </p:nvSpPr>
         <p:spPr>
           <a:xfrm>
-            <a:off x="18973800" y="822960"/>
-            <a:ext cx="9171432" cy="1097280"/>
+            <a:off x="18087246" y="943851"/>
+            <a:ext cx="9994392" cy="1097280"/>
           </a:xfrm>
           <a:prstGeom prst="rect">
             <a:avLst/>
@@ -859,7 +899,9 @@
             <a:r>
               <a:rPr lang="en-US" sz="1600" b="1" dirty="0">
                 <a:solidFill>
-                  <a:schemeClr val="accent2"/>
+                  <a:schemeClr val="bg2">
+                    <a:lumMod val="25000"/>
+                  </a:schemeClr>
                 </a:solidFill>
               </a:rPr>
               <a:t>GitHub: </a:t>
@@ -867,7 +909,7 @@
             <a:r>
               <a:rPr lang="en-US" sz="1600" u="sng" dirty="0">
                 <a:solidFill>
-                  <a:schemeClr val="bg1"/>
+                  <a:srgbClr val="7030A0"/>
                 </a:solidFill>
                 <a:hlinkClick r:id="rId3">
                   <a:extLst>
@@ -879,7 +921,11 @@
               </a:rPr>
               <a:t>github.com/flavia-castro/CA1-Algorithms-Food-Storage-System</a:t>
             </a:r>
-            <a:endParaRPr lang="en-US" sz="1600" dirty="0"/>
+            <a:endParaRPr lang="en-US" sz="1600" dirty="0">
+              <a:solidFill>
+                <a:srgbClr val="7030A0"/>
+              </a:solidFill>
+            </a:endParaRPr>
           </a:p>
           <a:p>
             <a:pPr marL="0" indent="0">
@@ -891,20 +937,21 @@
             <a:r>
               <a:rPr lang="en-US" sz="1600" b="1" dirty="0">
                 <a:solidFill>
-                  <a:schemeClr val="accent2"/>
-                </a:solidFill>
-              </a:rPr>
-              <a:t>Video: </a:t>
+                  <a:schemeClr val="bg2">
+                    <a:lumMod val="25000"/>
+                  </a:schemeClr>
+                </a:solidFill>
+              </a:rPr>
+              <a:t>Video Presentation: </a:t>
             </a:r>
             <a:r>
               <a:rPr lang="en-US" sz="1600" dirty="0">
                 <a:solidFill>
-                  <a:schemeClr val="bg1"/>
-                </a:solidFill>
-              </a:rPr>
-              <a:t>[add Google Drive link]</a:t>
-            </a:r>
-            <a:endParaRPr lang="en-US" sz="1600" dirty="0"/>
+                  <a:srgbClr val="7030A0"/>
+                </a:solidFill>
+              </a:rPr>
+              <a:t>https://drive.google.com/file/d/1Ziob6ri6nQdibHtRjUXi7CGiZ11nPVpQ/view?usp=drive_link</a:t>
+            </a:r>
           </a:p>
         </p:txBody>
       </p:sp>
@@ -925,10 +972,17 @@
             </a:avLst>
           </a:prstGeom>
           <a:solidFill>
-            <a:schemeClr val="bg2"/>
+            <a:srgbClr val="FFF3DE"/>
           </a:solidFill>
           <a:ln/>
         </p:spPr>
+        <p:txBody>
+          <a:bodyPr/>
+          <a:lstStyle/>
+          <a:p>
+            <a:endParaRPr lang="en-US" dirty="0"/>
+          </a:p>
+        </p:txBody>
       </p:sp>
       <p:sp>
         <p:nvSpPr>
@@ -958,7 +1012,7 @@
         </p:nvSpPr>
         <p:spPr>
           <a:xfrm>
-            <a:off x="557784" y="2816352"/>
+            <a:off x="557784" y="2795087"/>
             <a:ext cx="402336" cy="402336"/>
           </a:xfrm>
           <a:prstGeom prst="rect">
@@ -1049,16 +1103,18 @@
           <a:bodyPr wrap="square" lIns="0" tIns="0" rIns="0" bIns="0" rtlCol="0" anchor="t"/>
           <a:lstStyle/>
           <a:p>
-            <a:pPr marL="0" indent="0" algn="just">
-              <a:buNone/>
-            </a:pPr>
-            <a:r>
-              <a:rPr lang="en-GB" sz="1500" dirty="0">
-                <a:solidFill>
-                  <a:schemeClr val="tx1"/>
-                </a:solidFill>
-              </a:rPr>
-              <a:t>A fast-food restaurant stores five types of food: Burger, Pizza, Fries, Sandwich and Hotdog. The storage unit is double-sided and will accept up to 8 trays. The chef can either add and remove food on the same side, or on opposite sides. Name, weight, best before date (maximum 14 days) and time of storage is assigned to each food item. The challenge was to select a suitable data structure and create a java program to model this process.</a:t>
+            <a:pPr algn="just"/>
+            <a:r>
+              <a:rPr lang="en-GB" sz="1500" dirty="0"/>
+              <a:t>A fast-food restaurant stores five types of food: Burger, Pizza, Fries, Sandwich and Hotdog. The storage unit is double-sided and will accept up to 8 trays. </a:t>
+            </a:r>
+            <a:r>
+              <a:rPr lang="en-US" sz="1500" dirty="0"/>
+              <a:t>The chef can either add and remove food only on the same side, or alternatively on opposite sides. Each food item is given: Name, weight, best before date (maximum 14 days), and time of storage. The challenge was to choose a appropriate data structure and write a java code to simulate this scenario.</a:t>
+            </a:r>
+            <a:r>
+              <a:rPr lang="en-GB" sz="1500" dirty="0"/>
+              <a:t>.</a:t>
             </a:r>
             <a:endParaRPr lang="en-US" sz="1500" dirty="0"/>
           </a:p>
@@ -1072,8 +1128,8 @@
         </p:nvSpPr>
         <p:spPr>
           <a:xfrm>
-            <a:off x="411480" y="6766560"/>
-            <a:ext cx="6720840" cy="4010152"/>
+            <a:off x="411480" y="6766559"/>
+            <a:ext cx="6720840" cy="4451751"/>
           </a:xfrm>
           <a:prstGeom prst="roundRect">
             <a:avLst>
@@ -1081,7 +1137,7 @@
             </a:avLst>
           </a:prstGeom>
           <a:solidFill>
-            <a:schemeClr val="bg2"/>
+            <a:srgbClr val="FFF3DE"/>
           </a:solidFill>
           <a:ln/>
         </p:spPr>
@@ -1114,7 +1170,7 @@
         </p:nvSpPr>
         <p:spPr>
           <a:xfrm>
-            <a:off x="554492" y="6920484"/>
+            <a:off x="554492" y="6926941"/>
             <a:ext cx="402336" cy="402336"/>
           </a:xfrm>
           <a:prstGeom prst="rect">
@@ -1150,7 +1206,7 @@
         </p:nvSpPr>
         <p:spPr>
           <a:xfrm>
-            <a:off x="1142878" y="6902958"/>
+            <a:off x="1142878" y="6951945"/>
             <a:ext cx="5660136" cy="438912"/>
           </a:xfrm>
           <a:prstGeom prst="rect">
@@ -1163,9 +1219,6 @@
           <a:bodyPr wrap="square" lIns="0" tIns="0" rIns="0" bIns="0" rtlCol="0" anchor="ctr"/>
           <a:lstStyle/>
           <a:p>
-            <a:pPr marL="0" indent="0">
-              <a:buNone/>
-            </a:pPr>
             <a:r>
               <a:rPr lang="en-US" sz="2300" b="1" dirty="0">
                 <a:solidFill>
@@ -1175,7 +1228,7 @@
                 <a:ea typeface="Cambria" pitchFamily="34" charset="-122"/>
                 <a:cs typeface="Lucida Sans Unicode" panose="020B0602030504020204" pitchFamily="34" charset="0"/>
               </a:rPr>
-              <a:t>Why a Queue?</a:t>
+              <a:t>Proposed Solution</a:t>
             </a:r>
             <a:endParaRPr lang="en-US" sz="2300" dirty="0">
               <a:latin typeface="Franklin Gothic Medium" panose="020B0603020102020204" pitchFamily="34" charset="0"/>
@@ -1192,8 +1245,8 @@
         </p:nvSpPr>
         <p:spPr>
           <a:xfrm>
-            <a:off x="667512" y="7476744"/>
-            <a:ext cx="6208776" cy="1478280"/>
+            <a:off x="667512" y="7558388"/>
+            <a:ext cx="6208776" cy="1722651"/>
           </a:xfrm>
           <a:prstGeom prst="rect">
             <a:avLst/>
@@ -1205,32 +1258,22 @@
           <a:bodyPr wrap="square" lIns="0" tIns="0" rIns="0" bIns="0" rtlCol="0" anchor="t"/>
           <a:lstStyle/>
           <a:p>
-            <a:pPr marL="0" indent="0" algn="just">
-              <a:buNone/>
-            </a:pPr>
-            <a:r>
-              <a:rPr lang="en-GB" sz="1500" dirty="0">
-                <a:solidFill>
-                  <a:schemeClr val="tx1"/>
-                </a:solidFill>
-              </a:rPr>
-              <a:t>The storage system we selected is a Circular Queue: First In, First Out (FIFO) (Goodrich, </a:t>
-            </a:r>
-            <a:r>
-              <a:rPr lang="en-GB" sz="1500" dirty="0" err="1">
-                <a:solidFill>
-                  <a:schemeClr val="tx1"/>
-                </a:solidFill>
-              </a:rPr>
+            <a:pPr algn="just"/>
+            <a:r>
+              <a:rPr lang="en-US" sz="1500" dirty="0"/>
+              <a:t>We have implemented the storing as a data structure: a Circular Queue: First In, First Out or FIFO (Goodrich, </a:t>
+            </a:r>
+            <a:r>
+              <a:rPr lang="en-US" sz="1500" dirty="0" err="1"/>
               <a:t>Tamassia</a:t>
             </a:r>
             <a:r>
-              <a:rPr lang="en-GB" sz="1500" dirty="0">
-                <a:solidFill>
-                  <a:schemeClr val="tx1"/>
-                </a:solidFill>
-              </a:rPr>
-              <a:t> and Goldwasser, 2014). Food enters at the rear and leaves from the front, which ensures that the oldest tray is always used first and helps to minimise food waste. A Stack would have the newest food on top and the older food trays would be allowed to expire, whereas a standard array with shifting would have to shift food after each removal.</a:t>
+              <a:rPr lang="en-US" sz="1500" dirty="0"/>
+              <a:t> and Goldwasser, 2014). Food is added at the back and picked up at the front, that way guaranteeing always the use of the most older tray first and also assisting in reducing food waste.</a:t>
+            </a:r>
+            <a:r>
+              <a:rPr lang="en-GB" sz="1500" dirty="0"/>
+              <a:t>. A Stack would have the newest food on top and the older food trays would be allowed to expire, whereas a standard array with shifting would have to shift food after each removal.</a:t>
             </a:r>
             <a:endParaRPr lang="en-US" sz="1500" dirty="0"/>
           </a:p>
@@ -1245,13 +1288,13 @@
           <p:nvPr>
             <p:extLst>
               <p:ext uri="{D42A27DB-BD31-4B8C-83A1-F6EECF244321}">
-                <p14:modId xmlns:p14="http://schemas.microsoft.com/office/powerpoint/2010/main" val="822352060"/>
+                <p14:modId xmlns:p14="http://schemas.microsoft.com/office/powerpoint/2010/main" val="273211272"/>
               </p:ext>
             </p:extLst>
           </p:nvPr>
         </p:nvGraphicFramePr>
         <p:xfrm>
-          <a:off x="662636" y="9034272"/>
+          <a:off x="678965" y="9360848"/>
           <a:ext cx="6208776" cy="1536192"/>
         </p:xfrm>
         <a:graphic>
@@ -2236,8 +2279,8 @@
         </p:nvSpPr>
         <p:spPr>
           <a:xfrm>
-            <a:off x="411480" y="11069320"/>
-            <a:ext cx="6720840" cy="3579368"/>
+            <a:off x="411480" y="11510916"/>
+            <a:ext cx="6720840" cy="3137771"/>
           </a:xfrm>
           <a:prstGeom prst="roundRect">
             <a:avLst>
@@ -2245,7 +2288,7 @@
             </a:avLst>
           </a:prstGeom>
           <a:solidFill>
-            <a:schemeClr val="bg2"/>
+            <a:srgbClr val="FFF3DE"/>
           </a:solidFill>
           <a:ln/>
         </p:spPr>
@@ -2258,7 +2301,7 @@
         </p:nvSpPr>
         <p:spPr>
           <a:xfrm>
-            <a:off x="560568" y="11240262"/>
+            <a:off x="560568" y="11733544"/>
             <a:ext cx="402336" cy="402336"/>
           </a:xfrm>
           <a:prstGeom prst="ellipse">
@@ -2278,7 +2321,7 @@
         </p:nvSpPr>
         <p:spPr>
           <a:xfrm>
-            <a:off x="560568" y="11240262"/>
+            <a:off x="560568" y="11733546"/>
             <a:ext cx="402336" cy="402336"/>
           </a:xfrm>
           <a:prstGeom prst="rect">
@@ -2314,7 +2357,7 @@
         </p:nvSpPr>
         <p:spPr>
           <a:xfrm>
-            <a:off x="1109208" y="11221974"/>
+            <a:off x="1109208" y="11744499"/>
             <a:ext cx="5660136" cy="438912"/>
           </a:xfrm>
           <a:prstGeom prst="rect">
@@ -2356,7 +2399,7 @@
         </p:nvSpPr>
         <p:spPr>
           <a:xfrm>
-            <a:off x="667512" y="11836709"/>
+            <a:off x="667512" y="12440879"/>
             <a:ext cx="3060801" cy="274320"/>
           </a:xfrm>
           <a:prstGeom prst="rect">
@@ -2392,7 +2435,7 @@
         </p:nvSpPr>
         <p:spPr>
           <a:xfrm>
-            <a:off x="3789184" y="11836709"/>
+            <a:off x="3789184" y="12440879"/>
             <a:ext cx="2967228" cy="274320"/>
           </a:xfrm>
           <a:prstGeom prst="rect">
@@ -2428,8 +2471,8 @@
         </p:nvSpPr>
         <p:spPr>
           <a:xfrm>
-            <a:off x="697361" y="12163236"/>
-            <a:ext cx="3080126" cy="2351415"/>
+            <a:off x="697361" y="12767406"/>
+            <a:ext cx="3080126" cy="1699721"/>
           </a:xfrm>
           <a:prstGeom prst="rect">
             <a:avLst/>
@@ -2442,9 +2485,6 @@
           <a:lstStyle/>
           <a:p>
             <a:pPr marL="285750" indent="-285750">
-              <a:lnSpc>
-                <a:spcPct val="150000"/>
-              </a:lnSpc>
               <a:buClr>
                 <a:srgbClr val="00CC66"/>
               </a:buClr>
@@ -2467,9 +2507,6 @@
           </a:p>
           <a:p>
             <a:pPr marL="285750" indent="-285750">
-              <a:lnSpc>
-                <a:spcPct val="150000"/>
-              </a:lnSpc>
               <a:buClr>
                 <a:srgbClr val="00CC66"/>
               </a:buClr>
@@ -2484,9 +2521,6 @@
           </a:p>
           <a:p>
             <a:pPr marL="285750" indent="-285750">
-              <a:lnSpc>
-                <a:spcPct val="150000"/>
-              </a:lnSpc>
               <a:buClr>
                 <a:srgbClr val="00CC66"/>
               </a:buClr>
@@ -2501,9 +2535,6 @@
           </a:p>
           <a:p>
             <a:pPr marL="285750" indent="-285750">
-              <a:lnSpc>
-                <a:spcPct val="150000"/>
-              </a:lnSpc>
               <a:buClr>
                 <a:srgbClr val="00CC66"/>
               </a:buClr>
@@ -2518,9 +2549,6 @@
           </a:p>
           <a:p>
             <a:pPr marL="285750" indent="-285750">
-              <a:lnSpc>
-                <a:spcPct val="150000"/>
-              </a:lnSpc>
               <a:buClr>
                 <a:srgbClr val="00CC66"/>
               </a:buClr>
@@ -2552,7 +2580,7 @@
             </a:avLst>
           </a:prstGeom>
           <a:solidFill>
-            <a:schemeClr val="bg2"/>
+            <a:srgbClr val="FFF3DE"/>
           </a:solidFill>
           <a:ln/>
         </p:spPr>
@@ -2663,8 +2691,8 @@
         </p:nvSpPr>
         <p:spPr>
           <a:xfrm>
-            <a:off x="7647384" y="3402439"/>
-            <a:ext cx="6391656" cy="3213524"/>
+            <a:off x="7647384" y="3402438"/>
+            <a:ext cx="6391656" cy="3939431"/>
           </a:xfrm>
           <a:prstGeom prst="rect">
             <a:avLst/>
@@ -2676,33 +2704,24 @@
           <a:bodyPr wrap="square" lIns="0" tIns="0" rIns="0" bIns="0" rtlCol="0" anchor="t"/>
           <a:lstStyle/>
           <a:p>
-            <a:pPr marL="0" indent="0" algn="just">
-              <a:buNone/>
-            </a:pPr>
-            <a:r>
-              <a:rPr lang="en-GB" sz="1500" dirty="0">
-                <a:solidFill>
-                  <a:schemeClr val="tx1"/>
-                </a:solidFill>
-              </a:rPr>
+            <a:pPr algn="just"/>
+            <a:r>
+              <a:rPr lang="en-GB" sz="1500" dirty="0"/>
               <a:t>We implemented our own circular queue using an array with 8 slots for </a:t>
             </a:r>
             <a:r>
-              <a:rPr lang="en-GB" sz="1500" dirty="0" err="1">
-                <a:solidFill>
-                  <a:schemeClr val="tx1"/>
-                </a:solidFill>
-              </a:rPr>
+              <a:rPr lang="en-GB" sz="1500" dirty="0" err="1"/>
               <a:t>FoodItem</a:t>
             </a:r>
             <a:r>
-              <a:rPr lang="en-GB" sz="1500" dirty="0">
-                <a:solidFill>
-                  <a:schemeClr val="tx1"/>
-                </a:solidFill>
-              </a:rPr>
-              <a:t> objects. Two variables track the storage: front (next item to be removed) and count (number of stored items).</a:t>
-            </a:r>
+              <a:rPr lang="en-GB" sz="1500" dirty="0"/>
+              <a:t> objects. </a:t>
+            </a:r>
+            <a:r>
+              <a:rPr lang="en-US" sz="1500" dirty="0"/>
+              <a:t>The system uses two variables: front (item to be removed first) and count (the number of items).</a:t>
+            </a:r>
+            <a:endParaRPr lang="en-GB" sz="1500" dirty="0"/>
           </a:p>
           <a:p>
             <a:pPr marL="0" indent="0">
@@ -2719,7 +2738,7 @@
               <a:buClr>
                 <a:schemeClr val="accent1"/>
               </a:buClr>
-              <a:buFont typeface="Wingdings" panose="05000000000000000000" pitchFamily="2" charset="2"/>
+              <a:buFont typeface="Wingdings" pitchFamily="2" charset="2"/>
               <a:buChar char="§"/>
             </a:pPr>
             <a:r>
@@ -2995,7 +3014,7 @@
               <a:buClr>
                 <a:schemeClr val="accent1"/>
               </a:buClr>
-              <a:buFont typeface="Wingdings" panose="05000000000000000000" pitchFamily="2" charset="2"/>
+              <a:buFont typeface="Wingdings" pitchFamily="2" charset="2"/>
               <a:buChar char="§"/>
             </a:pPr>
             <a:r>
@@ -3285,7 +3304,7 @@
               <a:buClr>
                 <a:schemeClr val="accent1"/>
               </a:buClr>
-              <a:buFont typeface="Wingdings" panose="05000000000000000000" pitchFamily="2" charset="2"/>
+              <a:buFont typeface="Wingdings" pitchFamily="2" charset="2"/>
               <a:buChar char="§"/>
             </a:pPr>
             <a:r>
@@ -3350,7 +3369,7 @@
               <a:buClr>
                 <a:schemeClr val="accent1"/>
               </a:buClr>
-              <a:buFont typeface="Wingdings" panose="05000000000000000000" pitchFamily="2" charset="2"/>
+              <a:buFont typeface="Wingdings" pitchFamily="2" charset="2"/>
               <a:buChar char="§"/>
             </a:pPr>
             <a:r>
@@ -3412,18 +3431,11 @@
             </a:endParaRPr>
           </a:p>
           <a:p>
-            <a:pPr marL="0" indent="0" algn="just">
-              <a:buNone/>
-            </a:pPr>
-            <a:r>
-              <a:rPr lang="en-GB" sz="1500" dirty="0">
-                <a:solidFill>
-                  <a:schemeClr val="tx1"/>
-                </a:solidFill>
-              </a:rPr>
-              <a:t>The modulo operator (%) wraps the index from 7 back to 0, allowing empty slots to be reused without shifting items.</a:t>
-            </a:r>
-            <a:endParaRPr lang="en-US" sz="1500" dirty="0"/>
+            <a:pPr algn="just"/>
+            <a:r>
+              <a:rPr lang="en-US" sz="1500" dirty="0"/>
+              <a:t>The modulo operator (%) is used to wrap the indexes of 7 back to 0 so that the empty slots can be reused without moving the items.</a:t>
+            </a:r>
           </a:p>
         </p:txBody>
       </p:sp>
@@ -3444,7 +3456,7 @@
             </a:avLst>
           </a:prstGeom>
           <a:solidFill>
-            <a:schemeClr val="bg2"/>
+            <a:srgbClr val="FFF3DE"/>
           </a:solidFill>
           <a:ln/>
         </p:spPr>
@@ -3925,7 +3937,7 @@
             </a:avLst>
           </a:prstGeom>
           <a:solidFill>
-            <a:schemeClr val="bg2"/>
+            <a:srgbClr val="FFF3DE"/>
           </a:solidFill>
           <a:ln/>
         </p:spPr>
@@ -4108,42 +4120,10 @@
                   <a:schemeClr val="bg1"/>
                 </a:solidFill>
               </a:rPr>
-              <a:t>«</a:t>
-            </a:r>
-            <a:r>
-              <a:rPr lang="en-DE" sz="1100" b="1" i="1" dirty="0">
-                <a:solidFill>
-                  <a:schemeClr val="bg1"/>
-                </a:solidFill>
-              </a:rPr>
-              <a:t> </a:t>
-            </a:r>
-            <a:r>
-              <a:rPr lang="en-US" sz="1100" b="1" i="1" dirty="0">
-                <a:solidFill>
-                  <a:schemeClr val="bg1"/>
-                </a:solidFill>
-              </a:rPr>
-              <a:t>interface</a:t>
-            </a:r>
-            <a:r>
-              <a:rPr lang="en-DE" sz="1100" b="1" i="1" dirty="0">
-                <a:solidFill>
-                  <a:schemeClr val="bg1"/>
-                </a:solidFill>
-              </a:rPr>
-              <a:t> </a:t>
-            </a:r>
-            <a:r>
-              <a:rPr lang="en-US" sz="1100" b="1" i="1" dirty="0">
-                <a:solidFill>
-                  <a:schemeClr val="bg1"/>
-                </a:solidFill>
-              </a:rPr>
-              <a:t>» </a:t>
-            </a:r>
-            <a:r>
-              <a:rPr lang="en-US" sz="1350" b="1" dirty="0">
+              <a:t>« interface » </a:t>
+            </a:r>
+            <a:r>
+              <a:rPr lang="en-US" sz="1350" b="1" dirty="0" err="1">
                 <a:solidFill>
                   <a:schemeClr val="bg1"/>
                 </a:solidFill>
@@ -5472,7 +5452,7 @@
             </a:avLst>
           </a:prstGeom>
           <a:solidFill>
-            <a:schemeClr val="bg2"/>
+            <a:srgbClr val="FFF3DE"/>
           </a:solidFill>
           <a:ln/>
         </p:spPr>
@@ -7716,18 +7696,19 @@
             </a:endParaRPr>
           </a:p>
           <a:p>
-            <a:pPr marL="0" indent="0" algn="just">
-              <a:buNone/>
-            </a:pPr>
+            <a:pPr algn="just"/>
             <a:r>
               <a:rPr lang="en-US" sz="1400" dirty="0">
                 <a:solidFill>
                   <a:schemeClr val="tx1"/>
                 </a:solidFill>
               </a:rPr>
-              <a:t>Add, remove and peek only change front or count, so they are O(1). Display prints every item: O(n). Search is linear: O(1) when the food is at the front, O(n) in the worst case. Space is O(n), one fixed array of 8.</a:t>
-            </a:r>
-            <a:endParaRPr lang="en-US" sz="1400" dirty="0"/>
+              <a:t>Add, remove and peek only change front or count, so they are O(1). Display prints every item: O(n). </a:t>
+            </a:r>
+            <a:r>
+              <a:rPr lang="en-US" sz="1400" dirty="0"/>
+              <a:t>Search is linear: O(1) when the item found is at the front, the worst case is O(n). Storage space is O(n), one fixed array of 8.</a:t>
+            </a:r>
           </a:p>
         </p:txBody>
       </p:sp>
@@ -7739,8 +7720,8 @@
         </p:nvSpPr>
         <p:spPr>
           <a:xfrm>
-            <a:off x="22174200" y="2651760"/>
-            <a:ext cx="6382512" cy="7744968"/>
+            <a:off x="22174200" y="2651761"/>
+            <a:ext cx="6382512" cy="7042766"/>
           </a:xfrm>
           <a:prstGeom prst="roundRect">
             <a:avLst>
@@ -7748,7 +7729,7 @@
             </a:avLst>
           </a:prstGeom>
           <a:solidFill>
-            <a:schemeClr val="bg2"/>
+            <a:srgbClr val="FFF3DE"/>
           </a:solidFill>
           <a:ln/>
         </p:spPr>
@@ -7889,69 +7870,6 @@
       </p:sp>
       <p:sp>
         <p:nvSpPr>
-          <p:cNvPr id="141" name="Menu screenshot frame"/>
-          <p:cNvSpPr/>
-          <p:nvPr/>
-        </p:nvSpPr>
-        <p:spPr>
-          <a:xfrm>
-            <a:off x="22465969" y="5284961"/>
-            <a:ext cx="5870448" cy="4206240"/>
-          </a:xfrm>
-          <a:prstGeom prst="roundRect">
-            <a:avLst>
-              <a:gd name="adj" fmla="val 1739"/>
-            </a:avLst>
-          </a:prstGeom>
-          <a:solidFill>
-            <a:schemeClr val="bg1"/>
-          </a:solidFill>
-          <a:ln w="19050">
-            <a:solidFill>
-              <a:schemeClr val="accent4"/>
-            </a:solidFill>
-            <a:prstDash val="dash"/>
-          </a:ln>
-        </p:spPr>
-      </p:sp>
-      <p:sp>
-        <p:nvSpPr>
-          <p:cNvPr id="142" name="Menu screenshot label"/>
-          <p:cNvSpPr txBox="1"/>
-          <p:nvPr/>
-        </p:nvSpPr>
-        <p:spPr>
-          <a:xfrm>
-            <a:off x="22465969" y="5301789"/>
-            <a:ext cx="5870448" cy="4206240"/>
-          </a:xfrm>
-          <a:prstGeom prst="rect">
-            <a:avLst/>
-          </a:prstGeom>
-          <a:noFill/>
-          <a:ln/>
-        </p:spPr>
-        <p:txBody>
-          <a:bodyPr wrap="square" lIns="1905" tIns="1905" rIns="1905" bIns="1905" rtlCol="0" anchor="ctr"/>
-          <a:lstStyle/>
-          <a:p>
-            <a:pPr marL="0" indent="0" algn="ctr">
-              <a:buNone/>
-            </a:pPr>
-            <a:r>
-              <a:rPr lang="en-US" sz="1400" i="1" dirty="0">
-                <a:solidFill>
-                  <a:schemeClr val="accent6"/>
-                </a:solidFill>
-              </a:rPr>
-              <a:t>Insert screenshot: NetBeans menu showing the operations and validation errors</a:t>
-            </a:r>
-            <a:endParaRPr lang="en-US" sz="1400" dirty="0"/>
-          </a:p>
-        </p:txBody>
-      </p:sp>
-      <p:sp>
-        <p:nvSpPr>
           <p:cNvPr id="145" name="References card"/>
           <p:cNvSpPr/>
           <p:nvPr/>
@@ -7967,7 +7885,7 @@
             </a:avLst>
           </a:prstGeom>
           <a:solidFill>
-            <a:schemeClr val="bg2"/>
+            <a:srgbClr val="FFF3DE"/>
           </a:solidFill>
           <a:ln/>
         </p:spPr>
@@ -8001,13 +7919,15 @@
                 <a:solidFill>
                   <a:schemeClr val="tx2"/>
                 </a:solidFill>
-                <a:latin typeface="Cambria" pitchFamily="34" charset="0"/>
+                <a:latin typeface="Franklin Gothic Medium" panose="020B0603020102020204" pitchFamily="34" charset="0"/>
                 <a:ea typeface="Cambria" pitchFamily="34" charset="-122"/>
                 <a:cs typeface="Cambria" pitchFamily="34" charset="-120"/>
               </a:rPr>
               <a:t>References</a:t>
             </a:r>
-            <a:endParaRPr lang="en-US" sz="2000" dirty="0"/>
+            <a:endParaRPr lang="en-US" sz="2000" dirty="0">
+              <a:latin typeface="Franklin Gothic Medium" panose="020B0603020102020204" pitchFamily="34" charset="0"/>
+            </a:endParaRPr>
           </a:p>
         </p:txBody>
       </p:sp>
@@ -8032,46 +7952,324 @@
           <a:bodyPr wrap="square" lIns="0" tIns="0" rIns="0" bIns="0" rtlCol="0" anchor="ctr"/>
           <a:lstStyle/>
           <a:p>
-            <a:pPr marL="0" indent="0">
-              <a:buNone/>
-            </a:pPr>
+            <a:r>
+              <a:rPr lang="en-US" sz="1200" dirty="0" err="1">
+                <a:solidFill>
+                  <a:schemeClr val="accent6"/>
+                </a:solidFill>
+              </a:rPr>
+              <a:t>Programiz</a:t>
+            </a:r>
             <a:r>
               <a:rPr lang="en-US" sz="1200" dirty="0">
                 <a:solidFill>
                   <a:schemeClr val="accent6"/>
                 </a:solidFill>
               </a:rPr>
-              <a:t>Goodrich, M.T., Tamassia, R. and Goldwasser, M.H. (2014) Data Structures and Algorithms in Java. 6th edn. Hoboken: Wiley.</a:t>
-            </a:r>
-            <a:endParaRPr lang="en-US" sz="1200" dirty="0"/>
+              <a:t> (2017). </a:t>
+            </a:r>
+            <a:r>
+              <a:rPr lang="en-US" sz="1200" i="1" dirty="0">
+                <a:solidFill>
+                  <a:schemeClr val="accent6"/>
+                </a:solidFill>
+              </a:rPr>
+              <a:t>Circular queue data structure</a:t>
+            </a:r>
+            <a:r>
+              <a:rPr lang="en-US" sz="1200" dirty="0">
+                <a:solidFill>
+                  <a:schemeClr val="accent6"/>
+                </a:solidFill>
+              </a:rPr>
+              <a:t>. [online] </a:t>
+            </a:r>
+            <a:r>
+              <a:rPr lang="en-US" sz="1200" dirty="0" err="1">
+                <a:solidFill>
+                  <a:schemeClr val="accent6"/>
+                </a:solidFill>
+              </a:rPr>
+              <a:t>Programiz</a:t>
+            </a:r>
+            <a:r>
+              <a:rPr lang="en-US" sz="1200" dirty="0">
+                <a:solidFill>
+                  <a:schemeClr val="accent6"/>
+                </a:solidFill>
+              </a:rPr>
+              <a:t>. Available at: https://</a:t>
+            </a:r>
+            <a:r>
+              <a:rPr lang="en-US" sz="1200" dirty="0" err="1">
+                <a:solidFill>
+                  <a:schemeClr val="accent6"/>
+                </a:solidFill>
+              </a:rPr>
+              <a:t>www.programiz.com</a:t>
+            </a:r>
+            <a:r>
+              <a:rPr lang="en-US" sz="1200" dirty="0">
+                <a:solidFill>
+                  <a:schemeClr val="accent6"/>
+                </a:solidFill>
+              </a:rPr>
+              <a:t>/</a:t>
+            </a:r>
+            <a:r>
+              <a:rPr lang="en-US" sz="1200" dirty="0" err="1">
+                <a:solidFill>
+                  <a:schemeClr val="accent6"/>
+                </a:solidFill>
+              </a:rPr>
+              <a:t>dsa</a:t>
+            </a:r>
+            <a:r>
+              <a:rPr lang="en-US" sz="1200" dirty="0">
+                <a:solidFill>
+                  <a:schemeClr val="accent6"/>
+                </a:solidFill>
+              </a:rPr>
+              <a:t>/circular-queue [Accessed 11 Oct. 2026].</a:t>
+            </a:r>
           </a:p>
           <a:p>
-            <a:pPr marL="0" indent="0">
-              <a:buNone/>
-            </a:pPr>
+            <a:r>
+              <a:rPr lang="en-US" sz="1200" dirty="0" err="1">
+                <a:solidFill>
+                  <a:schemeClr val="accent6"/>
+                </a:solidFill>
+              </a:rPr>
+              <a:t>docs.oracle.com</a:t>
+            </a:r>
             <a:r>
               <a:rPr lang="en-US" sz="1200" dirty="0">
                 <a:solidFill>
                   <a:schemeClr val="accent6"/>
                 </a:solidFill>
               </a:rPr>
-              <a:t>Oracle (no date) Interface Queue&lt;E&gt; (Java Platform SE 8). Available at: https://docs.oracle.com/javase/8/docs/api/java/util/Queue.html (Accessed: [date]).</a:t>
-            </a:r>
-            <a:endParaRPr lang="en-US" sz="1200" dirty="0"/>
+              <a:t>. (n.d.). </a:t>
+            </a:r>
+            <a:r>
+              <a:rPr lang="en-US" sz="1200" i="1" dirty="0">
+                <a:solidFill>
+                  <a:schemeClr val="accent6"/>
+                </a:solidFill>
+              </a:rPr>
+              <a:t>Lesson: Exceptions (the </a:t>
+            </a:r>
+            <a:r>
+              <a:rPr lang="en-US" sz="1200" i="1" dirty="0" err="1">
+                <a:solidFill>
+                  <a:schemeClr val="accent6"/>
+                </a:solidFill>
+              </a:rPr>
+              <a:t>java</a:t>
+            </a:r>
+            <a:r>
+              <a:rPr lang="en-US" sz="1200" i="1" baseline="30000" dirty="0" err="1">
+                <a:solidFill>
+                  <a:schemeClr val="accent6"/>
+                </a:solidFill>
+              </a:rPr>
+              <a:t>TM</a:t>
+            </a:r>
+            <a:r>
+              <a:rPr lang="en-US" sz="1200" i="1" dirty="0">
+                <a:solidFill>
+                  <a:schemeClr val="accent6"/>
+                </a:solidFill>
+              </a:rPr>
+              <a:t> tutorials &gt; essential java classes)</a:t>
+            </a:r>
+            <a:r>
+              <a:rPr lang="en-US" sz="1200" dirty="0">
+                <a:solidFill>
+                  <a:schemeClr val="accent6"/>
+                </a:solidFill>
+              </a:rPr>
+              <a:t>. [online] Available at: https://</a:t>
+            </a:r>
+            <a:r>
+              <a:rPr lang="en-US" sz="1200" dirty="0" err="1">
+                <a:solidFill>
+                  <a:schemeClr val="accent6"/>
+                </a:solidFill>
+              </a:rPr>
+              <a:t>docs.oracle.com</a:t>
+            </a:r>
+            <a:r>
+              <a:rPr lang="en-US" sz="1200" dirty="0">
+                <a:solidFill>
+                  <a:schemeClr val="accent6"/>
+                </a:solidFill>
+              </a:rPr>
+              <a:t>/</a:t>
+            </a:r>
+            <a:r>
+              <a:rPr lang="en-US" sz="1200" dirty="0" err="1">
+                <a:solidFill>
+                  <a:schemeClr val="accent6"/>
+                </a:solidFill>
+              </a:rPr>
+              <a:t>javase</a:t>
+            </a:r>
+            <a:r>
+              <a:rPr lang="en-US" sz="1200" dirty="0">
+                <a:solidFill>
+                  <a:schemeClr val="accent6"/>
+                </a:solidFill>
+              </a:rPr>
+              <a:t>/tutorial/essential/exceptions/ [Accessed 12 Oct. 2026].</a:t>
+            </a:r>
           </a:p>
           <a:p>
-            <a:pPr marL="0" indent="0">
-              <a:buNone/>
-            </a:pPr>
             <a:r>
               <a:rPr lang="en-US" sz="1200" dirty="0">
                 <a:solidFill>
                   <a:schemeClr val="accent6"/>
                 </a:solidFill>
               </a:rPr>
-              <a:t>Oracle (no date) Class LocalDate (Java Platform SE 8). Available at: https://docs.oracle.com/javase/8/docs/api/java/time/LocalDate.html (Accessed: [date]).</a:t>
-            </a:r>
-            <a:endParaRPr lang="en-US" sz="1200" dirty="0"/>
+              <a:t>Oracle (n.d.). </a:t>
+            </a:r>
+            <a:r>
+              <a:rPr lang="en-US" sz="1200" i="1" dirty="0">
+                <a:solidFill>
+                  <a:schemeClr val="accent6"/>
+                </a:solidFill>
+              </a:rPr>
+              <a:t>Standard calendar</a:t>
+            </a:r>
+            <a:r>
+              <a:rPr lang="en-US" sz="1200" dirty="0">
+                <a:solidFill>
+                  <a:schemeClr val="accent6"/>
+                </a:solidFill>
+              </a:rPr>
+              <a:t>. [online] The </a:t>
+            </a:r>
+            <a:r>
+              <a:rPr lang="en-US" sz="1200" dirty="0" err="1">
+                <a:solidFill>
+                  <a:schemeClr val="accent6"/>
+                </a:solidFill>
+              </a:rPr>
+              <a:t>Java</a:t>
+            </a:r>
+            <a:r>
+              <a:rPr lang="en-US" sz="1200" baseline="30000" dirty="0" err="1">
+                <a:solidFill>
+                  <a:schemeClr val="accent6"/>
+                </a:solidFill>
+              </a:rPr>
+              <a:t>TM</a:t>
+            </a:r>
+            <a:r>
+              <a:rPr lang="en-US" sz="1200" dirty="0">
+                <a:solidFill>
+                  <a:schemeClr val="accent6"/>
+                </a:solidFill>
+              </a:rPr>
+              <a:t> Tutorials. Available at: https://</a:t>
+            </a:r>
+            <a:r>
+              <a:rPr lang="en-US" sz="1200" dirty="0" err="1">
+                <a:solidFill>
+                  <a:schemeClr val="accent6"/>
+                </a:solidFill>
+              </a:rPr>
+              <a:t>docs.oracle.com</a:t>
+            </a:r>
+            <a:r>
+              <a:rPr lang="en-US" sz="1200" dirty="0">
+                <a:solidFill>
+                  <a:schemeClr val="accent6"/>
+                </a:solidFill>
+              </a:rPr>
+              <a:t>/</a:t>
+            </a:r>
+            <a:r>
+              <a:rPr lang="en-US" sz="1200" dirty="0" err="1">
+                <a:solidFill>
+                  <a:schemeClr val="accent6"/>
+                </a:solidFill>
+              </a:rPr>
+              <a:t>javase</a:t>
+            </a:r>
+            <a:r>
+              <a:rPr lang="en-US" sz="1200" dirty="0">
+                <a:solidFill>
+                  <a:schemeClr val="accent6"/>
+                </a:solidFill>
+              </a:rPr>
+              <a:t>/tutorial/datetime/iso/</a:t>
+            </a:r>
+            <a:r>
+              <a:rPr lang="en-US" sz="1200" dirty="0" err="1">
+                <a:solidFill>
+                  <a:schemeClr val="accent6"/>
+                </a:solidFill>
+              </a:rPr>
+              <a:t>date.html</a:t>
+            </a:r>
+            <a:r>
+              <a:rPr lang="en-US" sz="1200" dirty="0">
+                <a:solidFill>
+                  <a:schemeClr val="accent6"/>
+                </a:solidFill>
+              </a:rPr>
+              <a:t> [Accessed 13 Oct. 2026].</a:t>
+            </a:r>
+          </a:p>
+          <a:p>
+            <a:r>
+              <a:rPr lang="en-US" sz="1200" i="1" dirty="0">
+                <a:solidFill>
+                  <a:schemeClr val="accent6"/>
+                </a:solidFill>
+              </a:rPr>
+              <a:t>Asymptotic complexity</a:t>
+            </a:r>
+            <a:r>
+              <a:rPr lang="en-US" sz="1200" dirty="0">
+                <a:solidFill>
+                  <a:schemeClr val="accent6"/>
+                </a:solidFill>
+              </a:rPr>
+              <a:t> (no date) </a:t>
+            </a:r>
+            <a:r>
+              <a:rPr lang="en-US" sz="1200" i="1" dirty="0" err="1">
+                <a:solidFill>
+                  <a:schemeClr val="accent6"/>
+                </a:solidFill>
+              </a:rPr>
+              <a:t>Cornell.edu</a:t>
+            </a:r>
+            <a:r>
+              <a:rPr lang="en-US" sz="1200" dirty="0">
+                <a:solidFill>
+                  <a:schemeClr val="accent6"/>
+                </a:solidFill>
+              </a:rPr>
+              <a:t>. Available at: https://</a:t>
+            </a:r>
+            <a:r>
+              <a:rPr lang="en-US" sz="1200" dirty="0" err="1">
+                <a:solidFill>
+                  <a:schemeClr val="accent6"/>
+                </a:solidFill>
+              </a:rPr>
+              <a:t>www.cs.cornell.edu</a:t>
+            </a:r>
+            <a:r>
+              <a:rPr lang="en-US" sz="1200" dirty="0">
+                <a:solidFill>
+                  <a:schemeClr val="accent6"/>
+                </a:solidFill>
+              </a:rPr>
+              <a:t>/courses/cs3110/2014fa/lectures/24/lec24.html [Accessed: 17 Oct. 2026].</a:t>
+            </a:r>
           </a:p>
         </p:txBody>
       </p:sp>
@@ -8089,8 +8287,8 @@
         </p:nvSpPr>
         <p:spPr>
           <a:xfrm>
-            <a:off x="22174200" y="10711543"/>
-            <a:ext cx="6382512" cy="3937145"/>
+            <a:off x="22174200" y="9981637"/>
+            <a:ext cx="6382512" cy="4667051"/>
           </a:xfrm>
           <a:prstGeom prst="roundRect">
             <a:avLst>
@@ -8098,7 +8296,7 @@
             </a:avLst>
           </a:prstGeom>
           <a:solidFill>
-            <a:schemeClr val="bg2"/>
+            <a:srgbClr val="FFF3DE"/>
           </a:solidFill>
           <a:ln/>
         </p:spPr>
@@ -8117,7 +8315,7 @@
         </p:nvGrpSpPr>
         <p:grpSpPr>
           <a:xfrm>
-            <a:off x="648472" y="4984390"/>
+            <a:off x="569412" y="5056632"/>
             <a:ext cx="4537578" cy="639170"/>
             <a:chOff x="441452" y="4930436"/>
             <a:chExt cx="4537578" cy="639170"/>
@@ -9119,8 +9317,8 @@
         </p:nvSpPr>
         <p:spPr>
           <a:xfrm>
-            <a:off x="3870511" y="12163237"/>
-            <a:ext cx="3080126" cy="1129311"/>
+            <a:off x="3870511" y="12767407"/>
+            <a:ext cx="3080126" cy="1699720"/>
           </a:xfrm>
           <a:prstGeom prst="rect">
             <a:avLst/>
@@ -9133,9 +9331,6 @@
           <a:lstStyle/>
           <a:p>
             <a:pPr marL="285750" indent="-285750">
-              <a:lnSpc>
-                <a:spcPct val="150000"/>
-              </a:lnSpc>
               <a:buClr>
                 <a:schemeClr val="accent1"/>
               </a:buClr>
@@ -9158,9 +9353,6 @@
           </a:p>
           <a:p>
             <a:pPr marL="285750" indent="-285750">
-              <a:lnSpc>
-                <a:spcPct val="150000"/>
-              </a:lnSpc>
               <a:buClr>
                 <a:schemeClr val="accent1"/>
               </a:buClr>
@@ -9175,9 +9367,6 @@
           </a:p>
           <a:p>
             <a:pPr marL="285750" indent="-285750">
-              <a:lnSpc>
-                <a:spcPct val="150000"/>
-              </a:lnSpc>
               <a:buClr>
                 <a:schemeClr val="accent1"/>
               </a:buClr>
@@ -9192,9 +9381,6 @@
           </a:p>
           <a:p>
             <a:pPr marL="285750" indent="-285750">
-              <a:lnSpc>
-                <a:spcPct val="150000"/>
-              </a:lnSpc>
               <a:buClr>
                 <a:schemeClr val="accent1"/>
               </a:buClr>
@@ -9209,9 +9395,6 @@
           </a:p>
           <a:p>
             <a:pPr marL="285750" indent="-285750">
-              <a:lnSpc>
-                <a:spcPct val="150000"/>
-              </a:lnSpc>
               <a:buClr>
                 <a:schemeClr val="accent1"/>
               </a:buClr>
@@ -9263,15 +9446,16 @@
               </a:avLst>
             </a:prstGeom>
             <a:solidFill>
-              <a:schemeClr val="accent2">
-                <a:lumMod val="40000"/>
-                <a:lumOff val="60000"/>
+              <a:schemeClr val="tx1">
+                <a:lumMod val="25000"/>
+                <a:lumOff val="75000"/>
               </a:schemeClr>
             </a:solidFill>
             <a:ln w="12700">
               <a:solidFill>
-                <a:schemeClr val="accent2">
+                <a:schemeClr val="tx1">
                   <a:lumMod val="75000"/>
+                  <a:lumOff val="25000"/>
                 </a:schemeClr>
               </a:solidFill>
               <a:prstDash val="solid"/>
@@ -9287,6 +9471,177 @@
           <p:spPr>
             <a:xfrm>
               <a:off x="8173012" y="7962719"/>
+              <a:ext cx="875047" cy="954024"/>
+            </a:xfrm>
+            <a:prstGeom prst="roundRect">
+              <a:avLst>
+                <a:gd name="adj" fmla="val 10127"/>
+              </a:avLst>
+            </a:prstGeom>
+            <a:solidFill>
+              <a:schemeClr val="tx1">
+                <a:lumMod val="25000"/>
+                <a:lumOff val="75000"/>
+              </a:schemeClr>
+            </a:solidFill>
+            <a:ln w="12700">
+              <a:solidFill>
+                <a:schemeClr val="tx1">
+                  <a:lumMod val="75000"/>
+                  <a:lumOff val="25000"/>
+                </a:schemeClr>
+              </a:solidFill>
+              <a:prstDash val="solid"/>
+            </a:ln>
+          </p:spPr>
+        </p:sp>
+        <p:sp>
+          <p:nvSpPr>
+            <p:cNvPr id="15" name="Tray 2"/>
+            <p:cNvSpPr/>
+            <p:nvPr/>
+          </p:nvSpPr>
+          <p:spPr>
+            <a:xfrm>
+              <a:off x="9081791" y="7962719"/>
+              <a:ext cx="875047" cy="954024"/>
+            </a:xfrm>
+            <a:prstGeom prst="roundRect">
+              <a:avLst>
+                <a:gd name="adj" fmla="val 10127"/>
+              </a:avLst>
+            </a:prstGeom>
+            <a:solidFill>
+              <a:schemeClr val="tx1">
+                <a:lumMod val="25000"/>
+                <a:lumOff val="75000"/>
+              </a:schemeClr>
+            </a:solidFill>
+            <a:ln w="12700">
+              <a:solidFill>
+                <a:schemeClr val="tx1">
+                  <a:lumMod val="75000"/>
+                  <a:lumOff val="25000"/>
+                </a:schemeClr>
+              </a:solidFill>
+              <a:prstDash val="solid"/>
+            </a:ln>
+          </p:spPr>
+        </p:sp>
+        <p:sp>
+          <p:nvSpPr>
+            <p:cNvPr id="16" name="Tray 3"/>
+            <p:cNvSpPr/>
+            <p:nvPr/>
+          </p:nvSpPr>
+          <p:spPr>
+            <a:xfrm>
+              <a:off x="9990570" y="7962719"/>
+              <a:ext cx="875047" cy="954024"/>
+            </a:xfrm>
+            <a:prstGeom prst="roundRect">
+              <a:avLst>
+                <a:gd name="adj" fmla="val 10127"/>
+              </a:avLst>
+            </a:prstGeom>
+            <a:solidFill>
+              <a:schemeClr val="tx1">
+                <a:lumMod val="25000"/>
+                <a:lumOff val="75000"/>
+              </a:schemeClr>
+            </a:solidFill>
+            <a:ln w="12700">
+              <a:solidFill>
+                <a:schemeClr val="tx1">
+                  <a:lumMod val="75000"/>
+                  <a:lumOff val="25000"/>
+                </a:schemeClr>
+              </a:solidFill>
+              <a:prstDash val="solid"/>
+            </a:ln>
+          </p:spPr>
+        </p:sp>
+        <p:sp>
+          <p:nvSpPr>
+            <p:cNvPr id="17" name="Tray 4"/>
+            <p:cNvSpPr/>
+            <p:nvPr/>
+          </p:nvSpPr>
+          <p:spPr>
+            <a:xfrm>
+              <a:off x="10899349" y="7962719"/>
+              <a:ext cx="875047" cy="954024"/>
+            </a:xfrm>
+            <a:prstGeom prst="roundRect">
+              <a:avLst>
+                <a:gd name="adj" fmla="val 10127"/>
+              </a:avLst>
+            </a:prstGeom>
+            <a:solidFill>
+              <a:schemeClr val="tx1">
+                <a:lumMod val="25000"/>
+                <a:lumOff val="75000"/>
+              </a:schemeClr>
+            </a:solidFill>
+            <a:ln w="12700">
+              <a:solidFill>
+                <a:schemeClr val="tx1">
+                  <a:lumMod val="75000"/>
+                  <a:lumOff val="25000"/>
+                </a:schemeClr>
+              </a:solidFill>
+              <a:prstDash val="solid"/>
+            </a:ln>
+          </p:spPr>
+        </p:sp>
+        <p:sp>
+          <p:nvSpPr>
+            <p:cNvPr id="18" name="Tray 5"/>
+            <p:cNvSpPr/>
+            <p:nvPr/>
+          </p:nvSpPr>
+          <p:spPr>
+            <a:xfrm>
+              <a:off x="11808128" y="7962719"/>
+              <a:ext cx="875047" cy="954024"/>
+            </a:xfrm>
+            <a:prstGeom prst="roundRect">
+              <a:avLst>
+                <a:gd name="adj" fmla="val 10127"/>
+              </a:avLst>
+            </a:prstGeom>
+            <a:solidFill>
+              <a:schemeClr val="accent2">
+                <a:lumMod val="40000"/>
+                <a:lumOff val="60000"/>
+              </a:schemeClr>
+            </a:solidFill>
+            <a:ln w="12700">
+              <a:solidFill>
+                <a:schemeClr val="accent2">
+                  <a:lumMod val="75000"/>
+                </a:schemeClr>
+              </a:solidFill>
+              <a:prstDash val="solid"/>
+            </a:ln>
+          </p:spPr>
+          <p:txBody>
+            <a:bodyPr/>
+            <a:lstStyle/>
+            <a:p>
+              <a:endParaRPr lang="en-US" dirty="0"/>
+            </a:p>
+          </p:txBody>
+        </p:sp>
+        <p:sp>
+          <p:nvSpPr>
+            <p:cNvPr id="20" name="Tray 6"/>
+            <p:cNvSpPr/>
+            <p:nvPr/>
+          </p:nvSpPr>
+          <p:spPr>
+            <a:xfrm>
+              <a:off x="12716907" y="7962719"/>
               <a:ext cx="875047" cy="954024"/>
             </a:xfrm>
             <a:prstGeom prst="roundRect">
@@ -9312,13 +9667,13 @@
         </p:sp>
         <p:sp>
           <p:nvSpPr>
-            <p:cNvPr id="15" name="Tray 2"/>
+            <p:cNvPr id="22" name="Tray 7"/>
             <p:cNvSpPr/>
             <p:nvPr/>
           </p:nvSpPr>
           <p:spPr>
             <a:xfrm>
-              <a:off x="9081791" y="7962719"/>
+              <a:off x="13625685" y="7962719"/>
               <a:ext cx="875047" cy="954024"/>
             </a:xfrm>
             <a:prstGeom prst="roundRect">
@@ -9337,160 +9692,6 @@
                 <a:schemeClr val="accent2">
                   <a:lumMod val="75000"/>
                 </a:schemeClr>
-              </a:solidFill>
-              <a:prstDash val="solid"/>
-            </a:ln>
-          </p:spPr>
-        </p:sp>
-        <p:sp>
-          <p:nvSpPr>
-            <p:cNvPr id="16" name="Tray 3"/>
-            <p:cNvSpPr/>
-            <p:nvPr/>
-          </p:nvSpPr>
-          <p:spPr>
-            <a:xfrm>
-              <a:off x="9990570" y="7962719"/>
-              <a:ext cx="875047" cy="954024"/>
-            </a:xfrm>
-            <a:prstGeom prst="roundRect">
-              <a:avLst>
-                <a:gd name="adj" fmla="val 10127"/>
-              </a:avLst>
-            </a:prstGeom>
-            <a:solidFill>
-              <a:schemeClr val="accent2">
-                <a:lumMod val="40000"/>
-                <a:lumOff val="60000"/>
-              </a:schemeClr>
-            </a:solidFill>
-            <a:ln w="12700">
-              <a:solidFill>
-                <a:schemeClr val="accent2">
-                  <a:lumMod val="75000"/>
-                </a:schemeClr>
-              </a:solidFill>
-              <a:prstDash val="solid"/>
-            </a:ln>
-          </p:spPr>
-        </p:sp>
-        <p:sp>
-          <p:nvSpPr>
-            <p:cNvPr id="17" name="Tray 4"/>
-            <p:cNvSpPr/>
-            <p:nvPr/>
-          </p:nvSpPr>
-          <p:spPr>
-            <a:xfrm>
-              <a:off x="10899349" y="7962719"/>
-              <a:ext cx="875047" cy="954024"/>
-            </a:xfrm>
-            <a:prstGeom prst="roundRect">
-              <a:avLst>
-                <a:gd name="adj" fmla="val 10127"/>
-              </a:avLst>
-            </a:prstGeom>
-            <a:solidFill>
-              <a:schemeClr val="accent2">
-                <a:lumMod val="40000"/>
-                <a:lumOff val="60000"/>
-              </a:schemeClr>
-            </a:solidFill>
-            <a:ln w="12700">
-              <a:solidFill>
-                <a:schemeClr val="accent2">
-                  <a:lumMod val="75000"/>
-                </a:schemeClr>
-              </a:solidFill>
-              <a:prstDash val="solid"/>
-            </a:ln>
-          </p:spPr>
-        </p:sp>
-        <p:sp>
-          <p:nvSpPr>
-            <p:cNvPr id="18" name="Tray 5"/>
-            <p:cNvSpPr/>
-            <p:nvPr/>
-          </p:nvSpPr>
-          <p:spPr>
-            <a:xfrm>
-              <a:off x="11808128" y="7962719"/>
-              <a:ext cx="875047" cy="954024"/>
-            </a:xfrm>
-            <a:prstGeom prst="roundRect">
-              <a:avLst>
-                <a:gd name="adj" fmla="val 10127"/>
-              </a:avLst>
-            </a:prstGeom>
-            <a:solidFill>
-              <a:schemeClr val="accent5">
-                <a:lumMod val="20000"/>
-                <a:lumOff val="80000"/>
-              </a:schemeClr>
-            </a:solidFill>
-            <a:ln w="12700">
-              <a:solidFill>
-                <a:schemeClr val="accent4"/>
-              </a:solidFill>
-              <a:prstDash val="solid"/>
-            </a:ln>
-          </p:spPr>
-        </p:sp>
-        <p:sp>
-          <p:nvSpPr>
-            <p:cNvPr id="20" name="Tray 6"/>
-            <p:cNvSpPr/>
-            <p:nvPr/>
-          </p:nvSpPr>
-          <p:spPr>
-            <a:xfrm>
-              <a:off x="12716907" y="7962719"/>
-              <a:ext cx="875047" cy="954024"/>
-            </a:xfrm>
-            <a:prstGeom prst="roundRect">
-              <a:avLst>
-                <a:gd name="adj" fmla="val 10127"/>
-              </a:avLst>
-            </a:prstGeom>
-            <a:solidFill>
-              <a:schemeClr val="accent5">
-                <a:lumMod val="20000"/>
-                <a:lumOff val="80000"/>
-              </a:schemeClr>
-            </a:solidFill>
-            <a:ln w="12700">
-              <a:solidFill>
-                <a:schemeClr val="accent4"/>
-              </a:solidFill>
-              <a:prstDash val="solid"/>
-            </a:ln>
-          </p:spPr>
-        </p:sp>
-        <p:sp>
-          <p:nvSpPr>
-            <p:cNvPr id="22" name="Tray 7"/>
-            <p:cNvSpPr/>
-            <p:nvPr/>
-          </p:nvSpPr>
-          <p:spPr>
-            <a:xfrm>
-              <a:off x="13625685" y="7962719"/>
-              <a:ext cx="875047" cy="954024"/>
-            </a:xfrm>
-            <a:prstGeom prst="roundRect">
-              <a:avLst>
-                <a:gd name="adj" fmla="val 10127"/>
-              </a:avLst>
-            </a:prstGeom>
-            <a:solidFill>
-              <a:schemeClr val="accent5">
-                <a:lumMod val="20000"/>
-                <a:lumOff val="80000"/>
-              </a:schemeClr>
-            </a:solidFill>
-            <a:ln w="12700">
-              <a:solidFill>
-                <a:schemeClr val="accent4"/>
               </a:solidFill>
               <a:prstDash val="solid"/>
             </a:ln>
@@ -9691,7 +9892,7 @@
             <a:lstStyle/>
             <a:p>
               <a:pPr algn="ctr"/>
-              <a:endParaRPr lang="en-IE"/>
+              <a:endParaRPr lang="en-IE" dirty="0"/>
             </a:p>
           </p:txBody>
         </p:sp>
@@ -9720,7 +9921,7 @@
           </p:spPr>
           <p:txBody>
             <a:bodyPr wrap="square" lIns="0" tIns="0" rIns="0" bIns="0" rtlCol="0" anchor="ctr">
-              <a:normAutofit/>
+              <a:normAutofit fontScale="92500"/>
             </a:bodyPr>
             <a:lstStyle/>
             <a:p>
@@ -9875,7 +10076,7 @@
           <p:spPr>
             <a:xfrm>
               <a:off x="11928898" y="8301232"/>
-              <a:ext cx="633507" cy="276999"/>
+              <a:ext cx="584712" cy="276999"/>
             </a:xfrm>
             <a:prstGeom prst="rect">
               <a:avLst/>
@@ -9891,10 +10092,7 @@
               <a:r>
                 <a:rPr lang="en-DE" sz="1200" dirty="0">
                   <a:solidFill>
-                    <a:schemeClr val="tx1">
-                      <a:lumMod val="50000"/>
-                      <a:lumOff val="50000"/>
-                    </a:schemeClr>
+                    <a:schemeClr val="accent2"/>
                   </a:solidFill>
                   <a:latin typeface="Cascadia Mono SemiBold" panose="020B0609020000020004" pitchFamily="49" charset="0"/>
                   <a:cs typeface="Cascadia Mono SemiBold" panose="020B0609020000020004" pitchFamily="49" charset="0"/>
@@ -9903,10 +10101,7 @@
               </a:r>
               <a:endParaRPr lang="en-IE" sz="1200" dirty="0">
                 <a:solidFill>
-                  <a:schemeClr val="tx1">
-                    <a:lumMod val="50000"/>
-                    <a:lumOff val="50000"/>
-                  </a:schemeClr>
+                  <a:schemeClr val="accent2"/>
                 </a:solidFill>
                 <a:latin typeface="Cascadia Mono SemiBold" panose="020B0609020000020004" pitchFamily="49" charset="0"/>
                 <a:cs typeface="Cascadia Mono SemiBold" panose="020B0609020000020004" pitchFamily="49" charset="0"/>
@@ -9929,7 +10124,7 @@
           <p:spPr>
             <a:xfrm>
               <a:off x="12837677" y="8310164"/>
-              <a:ext cx="633507" cy="276999"/>
+              <a:ext cx="584712" cy="276999"/>
             </a:xfrm>
             <a:prstGeom prst="rect">
               <a:avLst/>
@@ -9945,10 +10140,7 @@
               <a:r>
                 <a:rPr lang="en-DE" sz="1200" dirty="0">
                   <a:solidFill>
-                    <a:schemeClr val="tx1">
-                      <a:lumMod val="50000"/>
-                      <a:lumOff val="50000"/>
-                    </a:schemeClr>
+                    <a:schemeClr val="accent2"/>
                   </a:solidFill>
                   <a:latin typeface="Cascadia Mono SemiBold" panose="020B0609020000020004" pitchFamily="49" charset="0"/>
                   <a:cs typeface="Cascadia Mono SemiBold" panose="020B0609020000020004" pitchFamily="49" charset="0"/>
@@ -9957,10 +10149,7 @@
               </a:r>
               <a:endParaRPr lang="en-IE" sz="1200" dirty="0">
                 <a:solidFill>
-                  <a:schemeClr val="tx1">
-                    <a:lumMod val="50000"/>
-                    <a:lumOff val="50000"/>
-                  </a:schemeClr>
+                  <a:schemeClr val="accent2"/>
                 </a:solidFill>
                 <a:latin typeface="Cascadia Mono SemiBold" panose="020B0609020000020004" pitchFamily="49" charset="0"/>
                 <a:cs typeface="Cascadia Mono SemiBold" panose="020B0609020000020004" pitchFamily="49" charset="0"/>
@@ -9983,7 +10172,7 @@
           <p:spPr>
             <a:xfrm>
               <a:off x="13746455" y="8301232"/>
-              <a:ext cx="633507" cy="276999"/>
+              <a:ext cx="584712" cy="276999"/>
             </a:xfrm>
             <a:prstGeom prst="rect">
               <a:avLst/>
@@ -9999,10 +10188,7 @@
               <a:r>
                 <a:rPr lang="en-DE" sz="1200" dirty="0">
                   <a:solidFill>
-                    <a:schemeClr val="tx1">
-                      <a:lumMod val="50000"/>
-                      <a:lumOff val="50000"/>
-                    </a:schemeClr>
+                    <a:schemeClr val="accent2"/>
                   </a:solidFill>
                   <a:latin typeface="Cascadia Mono SemiBold" panose="020B0609020000020004" pitchFamily="49" charset="0"/>
                   <a:cs typeface="Cascadia Mono SemiBold" panose="020B0609020000020004" pitchFamily="49" charset="0"/>
@@ -10011,10 +10197,7 @@
               </a:r>
               <a:endParaRPr lang="en-IE" sz="1200" dirty="0">
                 <a:solidFill>
-                  <a:schemeClr val="tx1">
-                    <a:lumMod val="50000"/>
-                    <a:lumOff val="50000"/>
-                  </a:schemeClr>
+                  <a:schemeClr val="accent2"/>
                 </a:solidFill>
                 <a:latin typeface="Cascadia Mono SemiBold" panose="020B0609020000020004" pitchFamily="49" charset="0"/>
                 <a:cs typeface="Cascadia Mono SemiBold" panose="020B0609020000020004" pitchFamily="49" charset="0"/>
@@ -10517,7 +10700,7 @@
         </p:nvSpPr>
         <p:spPr>
           <a:xfrm>
-            <a:off x="22393655" y="10892408"/>
+            <a:off x="22382770" y="10168128"/>
             <a:ext cx="402336" cy="402336"/>
           </a:xfrm>
           <a:prstGeom prst="ellipse">
@@ -10543,7 +10726,7 @@
         </p:nvSpPr>
         <p:spPr>
           <a:xfrm>
-            <a:off x="22393655" y="10892408"/>
+            <a:off x="22393655" y="10162502"/>
             <a:ext cx="402336" cy="402336"/>
           </a:xfrm>
           <a:prstGeom prst="rect">
@@ -10585,7 +10768,7 @@
         </p:nvSpPr>
         <p:spPr>
           <a:xfrm>
-            <a:off x="22942295" y="10874120"/>
+            <a:off x="22942295" y="10144214"/>
             <a:ext cx="5321808" cy="438912"/>
           </a:xfrm>
           <a:prstGeom prst="rect">
@@ -10619,6 +10802,187 @@
           </a:p>
         </p:txBody>
       </p:sp>
+      <p:pic>
+        <p:nvPicPr>
+          <p:cNvPr id="23" name="Picture 22">
+            <a:extLst>
+              <a:ext uri="{FF2B5EF4-FFF2-40B4-BE49-F238E27FC236}">
+                <a16:creationId xmlns:a16="http://schemas.microsoft.com/office/drawing/2014/main" id="{9FCAD6AA-5971-1C27-D9EB-75E91E8B2E55}"/>
+              </a:ext>
+            </a:extLst>
+          </p:cNvPr>
+          <p:cNvPicPr>
+            <a:picLocks noChangeAspect="1"/>
+          </p:cNvPicPr>
+          <p:nvPr/>
+        </p:nvPicPr>
+        <p:blipFill>
+          <a:blip r:embed="rId9"/>
+          <a:stretch>
+            <a:fillRect/>
+          </a:stretch>
+        </p:blipFill>
+        <p:spPr>
+          <a:xfrm>
+            <a:off x="22393656" y="5337429"/>
+            <a:ext cx="5914390" cy="3847031"/>
+          </a:xfrm>
+          <a:prstGeom prst="rect">
+            <a:avLst/>
+          </a:prstGeom>
+        </p:spPr>
+      </p:pic>
+      <p:sp>
+        <p:nvSpPr>
+          <p:cNvPr id="38" name="OOP note">
+            <a:extLst>
+              <a:ext uri="{FF2B5EF4-FFF2-40B4-BE49-F238E27FC236}">
+                <a16:creationId xmlns:a16="http://schemas.microsoft.com/office/drawing/2014/main" id="{68A0BBA3-4F9A-807A-4153-6575E76D8753}"/>
+              </a:ext>
+            </a:extLst>
+          </p:cNvPr>
+          <p:cNvSpPr txBox="1"/>
+          <p:nvPr/>
+        </p:nvSpPr>
+        <p:spPr>
+          <a:xfrm>
+            <a:off x="23084442" y="9220578"/>
+            <a:ext cx="4391121" cy="121163"/>
+          </a:xfrm>
+          <a:prstGeom prst="rect">
+            <a:avLst/>
+          </a:prstGeom>
+          <a:noFill/>
+          <a:ln/>
+        </p:spPr>
+        <p:txBody>
+          <a:bodyPr wrap="square" lIns="0" tIns="0" rIns="0" bIns="0" rtlCol="0" anchor="ctr"/>
+          <a:lstStyle/>
+          <a:p>
+            <a:pPr algn="ctr"/>
+            <a:r>
+              <a:rPr lang="en-US" sz="1200" dirty="0"/>
+              <a:t>Figure 1: Invalid input and empty storage handled without crashing.</a:t>
+            </a:r>
+          </a:p>
+        </p:txBody>
+      </p:sp>
+      <p:pic>
+        <p:nvPicPr>
+          <p:cNvPr id="40" name="Picture 39">
+            <a:extLst>
+              <a:ext uri="{FF2B5EF4-FFF2-40B4-BE49-F238E27FC236}">
+                <a16:creationId xmlns:a16="http://schemas.microsoft.com/office/drawing/2014/main" id="{08070B25-615F-8D2B-3B3F-5ACA11D6F2A6}"/>
+              </a:ext>
+            </a:extLst>
+          </p:cNvPr>
+          <p:cNvPicPr>
+            <a:picLocks noChangeAspect="1"/>
+          </p:cNvPicPr>
+          <p:nvPr/>
+        </p:nvPicPr>
+        <p:blipFill>
+          <a:blip r:embed="rId10"/>
+          <a:stretch>
+            <a:fillRect/>
+          </a:stretch>
+        </p:blipFill>
+        <p:spPr>
+          <a:xfrm>
+            <a:off x="22667540" y="10658672"/>
+            <a:ext cx="5289923" cy="3435650"/>
+          </a:xfrm>
+          <a:prstGeom prst="rect">
+            <a:avLst/>
+          </a:prstGeom>
+        </p:spPr>
+      </p:pic>
+      <p:sp>
+        <p:nvSpPr>
+          <p:cNvPr id="41" name="OOP note">
+            <a:extLst>
+              <a:ext uri="{FF2B5EF4-FFF2-40B4-BE49-F238E27FC236}">
+                <a16:creationId xmlns:a16="http://schemas.microsoft.com/office/drawing/2014/main" id="{E9589C1C-76FF-DA32-D046-5B2E70C1F27F}"/>
+              </a:ext>
+            </a:extLst>
+          </p:cNvPr>
+          <p:cNvSpPr txBox="1"/>
+          <p:nvPr/>
+        </p:nvSpPr>
+        <p:spPr>
+          <a:xfrm>
+            <a:off x="22854719" y="14154201"/>
+            <a:ext cx="4876220" cy="121163"/>
+          </a:xfrm>
+          <a:prstGeom prst="rect">
+            <a:avLst/>
+          </a:prstGeom>
+          <a:noFill/>
+          <a:ln/>
+        </p:spPr>
+        <p:txBody>
+          <a:bodyPr wrap="square" lIns="0" tIns="0" rIns="0" bIns="0" rtlCol="0" anchor="ctr"/>
+          <a:lstStyle/>
+          <a:p>
+            <a:pPr algn="ctr"/>
+            <a:r>
+              <a:rPr lang="en-US" sz="1200" dirty="0"/>
+              <a:t>Figure 2: Git log showing 19 commits by both members on different dates.</a:t>
+            </a:r>
+          </a:p>
+        </p:txBody>
+      </p:sp>
+      <mc:AlternateContent xmlns:mc="http://schemas.openxmlformats.org/markup-compatibility/2006" xmlns:p14="http://schemas.microsoft.com/office/powerpoint/2010/main">
+        <mc:Choice Requires="p14">
+          <p:contentPart p14:bwMode="auto" r:id="rId11">
+            <p14:nvContentPartPr>
+              <p14:cNvPr id="43" name="Ink 42">
+                <a:extLst>
+                  <a:ext uri="{FF2B5EF4-FFF2-40B4-BE49-F238E27FC236}">
+                    <a16:creationId xmlns:a16="http://schemas.microsoft.com/office/drawing/2014/main" id="{FF8664CF-FAEC-FC5A-2E0B-56F033BD9AD0}"/>
+                  </a:ext>
+                </a:extLst>
+              </p14:cNvPr>
+              <p14:cNvContentPartPr/>
+              <p14:nvPr/>
+            </p14:nvContentPartPr>
+            <p14:xfrm>
+              <a:off x="22623480" y="2670480"/>
+              <a:ext cx="360" cy="360"/>
+            </p14:xfrm>
+          </p:contentPart>
+        </mc:Choice>
+        <mc:Fallback xmlns="">
+          <p:pic>
+            <p:nvPicPr>
+              <p:cNvPr id="43" name="Ink 42">
+                <a:extLst>
+                  <a:ext uri="{FF2B5EF4-FFF2-40B4-BE49-F238E27FC236}">
+                    <a16:creationId xmlns:a16="http://schemas.microsoft.com/office/drawing/2014/main" id="{FF8664CF-FAEC-FC5A-2E0B-56F033BD9AD0}"/>
+                  </a:ext>
+                </a:extLst>
+              </p:cNvPr>
+              <p:cNvPicPr/>
+              <p:nvPr/>
+            </p:nvPicPr>
+            <p:blipFill>
+              <a:blip r:embed="rId12"/>
+              <a:stretch>
+                <a:fillRect/>
+              </a:stretch>
+            </p:blipFill>
+            <p:spPr>
+              <a:xfrm>
+                <a:off x="22614120" y="2661120"/>
+                <a:ext cx="19080" cy="19080"/>
+              </a:xfrm>
+              <a:prstGeom prst="rect">
+                <a:avLst/>
+              </a:prstGeom>
+            </p:spPr>
+          </p:pic>
+        </mc:Fallback>
+      </mc:AlternateContent>
     </p:spTree>
   </p:cSld>
   <p:clrMapOvr>

</xml_diff>